<commit_message>
Deploying to gh-pages from @ tamanh-oxford/capacity-development@22bd806ae727289c7d77d8993bb31be801321da8 🚀
</commit_message>
<xml_diff>
--- a/vi/data-frameworks/course-outline.pptx
+++ b/vi/data-frameworks/course-outline.pptx
@@ -3224,7 +3224,7 @@
             <a:pPr lvl="0"/>
             <a:r>
               <a:rPr/>
-              <a:t>Bối cảnh toàn cầu về các tổ chức và khung khổ quản trị dữ liệu</a:t>
+              <a:t>Bức tranh toàn cầu về các tổ chức và khung khổ quản trị dữ liệu</a:t>
             </a:r>
           </a:p>
           <a:p>
@@ -3301,7 +3301,7 @@
             <a:pPr lvl="0"/>
             <a:r>
               <a:rPr/>
-              <a:t>Bối cảnh toàn cầu về các công nghệ sẵn có cho dữ liệu</a:t>
+              <a:t>Bức tranh toàn cầu về các công nghệ có sẵn cho dữ liệu</a:t>
             </a:r>
           </a:p>
           <a:p>
@@ -3315,7 +3315,7 @@
             <a:pPr lvl="0"/>
             <a:r>
               <a:rPr/>
-              <a:t>Bối cảnh toàn cầu về nguồn nhân lực cho dữ liệu</a:t>
+              <a:t>Bối cảnh công nghệ dữ liệu tại Việt Nam</a:t>
             </a:r>
           </a:p>
           <a:p>
@@ -3392,7 +3392,7 @@
             <a:pPr lvl="0"/>
             <a:r>
               <a:rPr/>
-              <a:t>Nguyên tắc hướng dẫn và thực hành tốt nhất cho việc xây dựng năng lực dữ liệu</a:t>
+              <a:t>Nguyên tắc hướng dẫn và các thực hành tốt nhất trong việc xây dựng năng lực dữ liệu</a:t>
             </a:r>
           </a:p>
           <a:p>
@@ -3406,7 +3406,7 @@
             <a:pPr lvl="0"/>
             <a:r>
               <a:rPr/>
-              <a:t>Hình mẫu quản lý cho việc xây dựng và triển khai thành công các cấu trúc và khung quản trị dữ liệu tại Việt Nam</a:t>
+              <a:t>Xây dựng và triển khai các cấu trúc và khung quản trị dữ liệu hiệu quả cho Việt Nam</a:t>
             </a:r>
           </a:p>
         </p:txBody>

</xml_diff>